<commit_message>
eic(dl-18.7): add Metropolia (talent/teaching) as third university across app + deck
Three-university structure with distinct, non-overlapping roles: LUT
(quantum-safe research/PhD), KTH TECoSA (safety assurance/testbed), Metropolia
(engineering-talent pipeline + teaching validation; Risto's 5/5 master's,
Varteva/Räsänen). WP doc v3.2 adds a €40K Metropolia line (advisory + YAMK
interns, from the pilot-infra line; total stays €2.5M, Lifetime majority 54%).
Update F11, deck HTML slide 9, deck outline, and regenerate the PPTX.

Co-Authored-By: Claude Opus 4.8 <noreply@anthropic.com>
Claude-Session: https://claude.ai/code/session_013JLDgz9dM6zxrM9CiWjV9f
</commit_message>
<xml_diff>
--- a/docs/eic/EIC_STEP1_PITCH_DECK.pptx
+++ b/docs/eic/EIC_STEP1_PITCH_DECK.pptx
@@ -6522,7 +6522,7 @@
                 </a:solidFill>
                 <a:latin typeface="Arial"/>
               </a:rPr>
-              <a:t>Scientific anchoring: </a:t>
+              <a:t>Academic anchoring: </a:t>
             </a:r>
             <a:r>
               <a:rPr sz="2000" b="1" i="0">
@@ -6540,7 +6540,7 @@
                 </a:solidFill>
                 <a:latin typeface="Arial"/>
               </a:rPr>
-              <a:t> + </a:t>
+              <a:t> (quantum-safe/PhD) · </a:t>
             </a:r>
             <a:r>
               <a:rPr sz="2000" b="1" i="0">
@@ -6549,7 +6549,7 @@
                 </a:solidFill>
                 <a:latin typeface="Arial"/>
               </a:rPr>
-              <a:t>KTH (TECoSA)</a:t>
+              <a:t>KTH TECoSA</a:t>
             </a:r>
             <a:r>
               <a:rPr sz="2000" b="0" i="0">
@@ -6558,7 +6558,25 @@
                 </a:solidFill>
                 <a:latin typeface="Arial"/>
               </a:rPr>
-              <a:t>. </a:t>
+              <a:t> (safety) · </a:t>
+            </a:r>
+            <a:r>
+              <a:rPr sz="2000" b="1" i="0">
+                <a:solidFill>
+                  <a:srgbClr val="FFFFFF"/>
+                </a:solidFill>
+                <a:latin typeface="Arial"/>
+              </a:rPr>
+              <a:t>Metropolia</a:t>
+            </a:r>
+            <a:r>
+              <a:rPr sz="2000" b="0" i="0">
+                <a:solidFill>
+                  <a:srgbClr val="EAF1FB"/>
+                </a:solidFill>
+                <a:latin typeface="Arial"/>
+              </a:rPr>
+              <a:t> (talent, 5/5 master's). </a:t>
             </a:r>
             <a:r>
               <a:rPr sz="2000" b="1" i="0">

</xml_diff>

<commit_message>
eic(dl-18.7): NVIDIA Connect ISV Partner badge + credential record
Confirmed via the NVIDIA Connect welcome email (to risto.anton@dws6.com,
2026-04-15): Lifetime Oy is an NVIDIA Connect ISV member; NVIDIA provides
official website badges in the member portal. Set F11 to the canonical
'NVIDIA Connect ISV Partner'; add a partner-badge strip to deck slide 1
(text chip — swap for the official portal PNG when downloaded); regenerate
PPTX + PDF. Save the membership as a verifiable credential record (§23);
original NVIDIA outreach = investor-outreach/INTRO_MAARTEN_VAN_SEGBROECK_NVIDIA.md.

Co-Authored-By: Claude Opus 4.8 <noreply@anthropic.com>
Claude-Session: https://claude.ai/code/session_013JLDgz9dM6zxrM9CiWjV9f
</commit_message>
<xml_diff>
--- a/docs/eic/EIC_STEP1_PITCH_DECK.pptx
+++ b/docs/eic/EIC_STEP1_PITCH_DECK.pptx
@@ -3241,7 +3241,7 @@
         <p:spPr>
           <a:xfrm>
             <a:off x="640080" y="4297680"/>
-            <a:ext cx="10515600" cy="1463040"/>
+            <a:ext cx="10515600" cy="1280160"/>
           </a:xfrm>
           <a:prstGeom prst="rect">
             <a:avLst/>
@@ -3269,6 +3269,40 @@
       <p:sp>
         <p:nvSpPr>
           <p:cNvPr id="6" name="TextBox 5"/>
+          <p:cNvSpPr txBox="1"/>
+          <p:nvPr/>
+        </p:nvSpPr>
+        <p:spPr>
+          <a:xfrm>
+            <a:off x="640080" y="5623560"/>
+            <a:ext cx="10972800" cy="548640"/>
+          </a:xfrm>
+          <a:prstGeom prst="rect">
+            <a:avLst/>
+          </a:prstGeom>
+          <a:noFill/>
+        </p:spPr>
+        <p:txBody>
+          <a:bodyPr wrap="square" anchor="t">
+            <a:spAutoFit/>
+          </a:bodyPr>
+          <a:lstStyle/>
+          <a:p>
+            <a:r>
+              <a:rPr sz="1300" b="1" i="0">
+                <a:solidFill>
+                  <a:srgbClr val="E8B64C"/>
+                </a:solidFill>
+                <a:latin typeface="Arial"/>
+              </a:rPr>
+              <a:t>NVIDIA Connect ISV Partner    ·    IBM Business Partner    ·    Amazon (AWS) Consulting Partner</a:t>
+            </a:r>
+          </a:p>
+        </p:txBody>
+      </p:sp>
+      <p:sp>
+        <p:nvSpPr>
+          <p:cNvPr id="7" name="TextBox 6"/>
           <p:cNvSpPr txBox="1"/>
           <p:nvPr/>
         </p:nvSpPr>

</xml_diff>

<commit_message>
docs(eic): reframe Risto's doctoral route to KTH, not LUT
Prof. Smolander (LUT) advised against a LUT dissertation on the Sep 2026
call; the doctoral route moves to KTH TECoSA (Prof. Törngren, licentiate /
industrial-postdoc per his 22.07.2026 reply). LUT stays as quantum-safe/ZK
research partner + IPR review via Innovation Services — not Risto's doctoral
home.

Corrected the partner table, honesty guardrails, founder bio, academic-
anchoring bullets, and video "why us" line across the EIC Step-1 pack;
rebuilt the pitch deck pptx + pdf from source. The 2 grant-funded industrial
doctoral candidates (Lifetime Oy payroll, LUT/KTH co-supervised) are hired
researchers, not Risto, and are unchanged. Historical 17.07.2026
correspondence is left as a sent record.

Co-Authored-By: Claude Opus 4.8 <noreply@anthropic.com>
Claude-Session: https://claude.ai/code/session_01C4bLK4YfVcTQtcSTmGubWm
</commit_message>
<xml_diff>
--- a/docs/eic/EIC_STEP1_PITCH_DECK.pptx
+++ b/docs/eic/EIC_STEP1_PITCH_DECK.pptx
@@ -6509,7 +6509,7 @@
                 </a:solidFill>
                 <a:latin typeface="Arial"/>
               </a:rPr>
-              <a:t> — Founder &amp; CEO; architect of DWS IQ + KYA; NVIDIA/IBM/AWS partner; doctoral discussions with LUT.</a:t>
+              <a:t> — Founder &amp; CEO; architect of DWS IQ + KYA; NVIDIA/IBM/AWS partner; doctoral route via KTH TECoSA (Prof. Törngren).</a:t>
             </a:r>
           </a:p>
           <a:p>
@@ -6610,7 +6610,7 @@
                 </a:solidFill>
                 <a:latin typeface="Arial"/>
               </a:rPr>
-              <a:t> (safety assurance) · </a:t>
+              <a:t> (safety assurance + Risto's doctoral route) · </a:t>
             </a:r>
             <a:r>
               <a:rPr sz="2000" b="1" i="0">

</xml_diff>